<commit_message>
Technical review of lessons 1-5: fix errors, add explanatory diagrams, tidy layouts
- L1: correct Big Data definition, add file-vs-database, data independence
  and two/three-tier diagrams
- L2: key-type mini ERDs, drawn crow's foot example, cleaner notation labels
- L4: TRUNCATE/DROP rollback, multi-row INSERT version note, COUNT(col) vs
  NULLs, Venn join diagrams, transaction states and view flow diagrams,
  wide results stacked under code
- L5: top-down/bottom-up flow, explicit FD arrows, lossless vs lossy split
- L3: wording fixes, mentorship PK/FK, reviewer notes on modelling issues
- pptlib: min-width aware rows, word-fit fonts, single-line ERD labels

Co-Authored-By: Claude Opus 5.5 <noreply@anthropic.com>
Claude-Session: https://claude.ai/code/session_01R46jZmLWPYVdN2LncsYeT8
</commit_message>
<xml_diff>
--- a/pptx/ITI_Database_Course_Lesson_3_Enhanced.pptx
+++ b/pptx/ITI_Database_Course_Lesson_3_Enhanced.pptx
@@ -3581,20 +3581,15 @@
           </a:bodyPr>
           <a:lstStyle/>
           <a:p>
-            <a:pPr indent="0" lvl="0" marL="0" rtl="0" algn="l">
-              <a:spcBef>
-                <a:spcPts val="0"/>
-              </a:spcBef>
-              <a:spcAft>
-                <a:spcPts val="0"/>
-              </a:spcAft>
-              <a:buNone/>
-            </a:pPr>
-            <a:r>
-              <a:rPr lang="en-US"/>
+            <a:r>
               <a:t>Three entity tables (step 1), one multi-valued table part_image (step 6), and the ternary produces (step 7). Factory computer system is composite, so only its parts (os, dbms, internet) become columns. In produces, the factory leg has cardinality 1: for a given (model, part) there is exactly one factory, so the PK is (model_name, part_id) and factory_city is a NOT NULL FK outside the key.</a:t>
             </a:r>
-            <a:endParaRPr/>
+          </a:p>
+          <a:p/>
+          <a:p>
+            <a:r>
+              <a:t>Reviewer note (technical): the narrative also says each model is produced at exactly one factory, so model_name -&gt; factory_city. In produces(model_name, part_id, factory_city) that is a partial dependency on the key, which Lesson 5 calls a 2NF violation. The normalized alternative: put factory_city (FK) in model, keep model_part(model_name, part_id) as a plain M:N, and enforce 'part made in the same factory' with a constraint. Worth showing as a bridge to Lesson 5.</a:t>
+            </a:r>
           </a:p>
         </p:txBody>
       </p:sp>
@@ -4055,20 +4050,15 @@
           </a:bodyPr>
           <a:lstStyle/>
           <a:p>
-            <a:pPr indent="0" lvl="0" marL="0" rtl="0" algn="l">
-              <a:spcBef>
-                <a:spcPts val="0"/>
-              </a:spcBef>
-              <a:spcAft>
-                <a:spcPts val="0"/>
-              </a:spcAft>
-              <a:buNone/>
-            </a:pPr>
-            <a:r>
-              <a:rPr lang="en-US"/>
+            <a:r>
               <a:t>Seven tables. bus: step 1 plus step-4 FK route_id (NOT NULL, total). route, town, driver: step 1. bus_option: step 6. route_town: step 5. drives: step 5 with relationship attributes, PK (driver_id, route_id, start_date). driver.last_route_id: step 4 FK from the last-route relationship.</a:t>
             </a:r>
-            <a:endParaRPr/>
+          </a:p>
+          <a:p/>
+          <a:p>
+            <a:r>
+              <a:t>Reviewer note: 'end' (and 'start' in some DBMSs) is a reserved word in SQL; name the route columns start_point and end_point when you write the CREATE TABLE in Lesson 4. The original narrative says 'station names' (plural) in each town; if a town can have several stations, station becomes a multi-valued attribute (town_station table, step 6).</a:t>
+            </a:r>
           </a:p>
         </p:txBody>
       </p:sp>
@@ -5477,20 +5467,15 @@
           </a:bodyPr>
           <a:lstStyle/>
           <a:p>
-            <a:pPr indent="0" lvl="0" marL="0" rtl="0" algn="l">
-              <a:spcBef>
-                <a:spcPts val="0"/>
-              </a:spcBef>
-              <a:spcAft>
-                <a:spcPts val="0"/>
-              </a:spcAft>
-              <a:buNone/>
-            </a:pPr>
-            <a:r>
-              <a:rPr lang="en-US"/>
+            <a:r>
               <a:t>A weak entity has no key of its own — it depends on an owner. Create a table for it, add the owner's PK as a FK, and the composite PK is (owner FK + the weak entity's partial key). Example: a dependent needs their employee's id plus their own name to be unique.</a:t>
             </a:r>
-            <a:endParaRPr/>
+          </a:p>
+          <a:p/>
+          <a:p>
+            <a:r>
+              <a:t>Reviewer note: with weekday alone as the partial key, an instructor cannot hold two office hours on the same day. If that can happen, the partial key is (weekday, start_time), so the PK becomes (instructor_id, weekday, start_time).</a:t>
+            </a:r>
           </a:p>
         </p:txBody>
       </p:sp>
@@ -5635,20 +5620,15 @@
           </a:bodyPr>
           <a:lstStyle/>
           <a:p>
-            <a:pPr indent="0" lvl="0" marL="0" rtl="0" algn="l">
-              <a:spcBef>
-                <a:spcPts val="0"/>
-              </a:spcBef>
-              <a:spcAft>
-                <a:spcPts val="0"/>
-              </a:spcAft>
-              <a:buNone/>
-            </a:pPr>
-            <a:r>
-              <a:rPr lang="en-US"/>
+            <a:r>
               <a:t>This is the slide the old deck got wrong. Three cases. Both sides mandatory: merge into one table — no row of either side exists without the other. One mandatory: put the FK on the mandatory side pointing to the optional side — the mandatory row then always has a value, and optional rows have none to orphan. Both optional: a separate link table so neither side carries NULLs.</a:t>
             </a:r>
-            <a:endParaRPr/>
+          </a:p>
+          <a:p/>
+          <a:p>
+            <a:r>
+              <a:t>Reviewer note: case C now shows a primary key for the link table. With a 1:1 relationship either FK can be the PK; the other gets UNIQUE. Another valid option for case C is an FK on either side that allows NULLs (plus UNIQUE).</a:t>
+            </a:r>
           </a:p>
         </p:txBody>
       </p:sp>
@@ -15130,7 +15110,7 @@
                 <a:cs typeface="Arial"/>
                 <a:sym typeface="Arial"/>
               </a:rPr>
-              <a:t>An instructor would need as many rows as courses he teach.</a:t>
+              <a:t>An instructor would need as many rows as courses they teach.</a:t>
             </a:r>
             <a:endParaRPr b="0" i="0" sz="1800" u="none" cap="none" strike="noStrike">
               <a:solidFill>
@@ -31997,7 +31977,7 @@
                 <a:cs typeface="Arial"/>
                 <a:sym typeface="Arial"/>
               </a:rPr>
-              <a:t>Same ITI example — </a:t>
+              <a:t>Same ideas on the COMPANY database — </a:t>
             </a:r>
             <a:r>
               <a:rPr b="0" i="0" lang="en-US" sz="2550" u="none" cap="none" strike="noStrike">
@@ -32069,7 +32049,7 @@
                 <a:cs typeface="Arial"/>
                 <a:sym typeface="Arial"/>
               </a:rPr>
-              <a:t>, joins and the rest. PostgreSQL dialect, from scratch.</a:t>
+              <a:t>, joins and the rest, with notes for Oracle, SQL Server and PostgreSQL.</a:t>
             </a:r>
             <a:endParaRPr b="0" i="0" sz="2550" u="none" cap="none" strike="noStrike">
               <a:solidFill>
@@ -44632,7 +44612,7 @@
                 <a:cs typeface="Courier New"/>
                 <a:sym typeface="Courier New"/>
               </a:rPr>
-              <a:t>instructor_id (FK, UK)</a:t>
+              <a:t>instructor_id (PK, FK)</a:t>
             </a:r>
             <a:endParaRPr b="0" i="0" sz="1800" u="none" cap="none" strike="noStrike">
               <a:solidFill>

</xml_diff>